<commit_message>
Fix Margin Bridge chart and add interactive hyperlinks to PowerPoint
- Margin Bridge: Show quarterly data only (Q1 2022 - Q3 2025)
- Margin Bridge: Calculate Q4 from annual 10-K (Q4 = Annual - Q1 - Q2 - Q3)
- Margin Bridge: Remove FY periods that were distorting the waterfall
- PowerPoint: Add "Click for interactive version" hyperlinks on all chart slides
- Hyperlinks open HTML files in browser for dropdowns, hover, zoom features

Co-Authored-By: Claude Opus 4.5 <noreply@anthropic.com>
</commit_message>
<xml_diff>
--- a/output/Target_Financial_Analysis.pptx
+++ b/output/Target_Financial_Analysis.pptx
@@ -3341,7 +3341,7 @@
         <p:spPr>
           <a:xfrm>
             <a:off x="457200" y="5029200"/>
-            <a:ext cx="8229600" cy="1371600"/>
+            <a:ext cx="8229600" cy="914400"/>
           </a:xfrm>
           <a:prstGeom prst="rect">
             <a:avLst/>
@@ -3363,6 +3363,40 @@
             </a:pPr>
             <a:r>
               <a:t>Three margin lines tracking profitability over time. Compression between lines reveals where profits leak.</a:t>
+            </a:r>
+          </a:p>
+        </p:txBody>
+      </p:sp>
+      <p:sp>
+        <p:nvSpPr>
+          <p:cNvPr id="5" name="TextBox 4"/>
+          <p:cNvSpPr txBox="1"/>
+          <p:nvPr/>
+        </p:nvSpPr>
+        <p:spPr>
+          <a:xfrm>
+            <a:off x="457200" y="6035040"/>
+            <a:ext cx="8229600" cy="365760"/>
+          </a:xfrm>
+          <a:prstGeom prst="rect">
+            <a:avLst/>
+          </a:prstGeom>
+          <a:noFill/>
+        </p:spPr>
+        <p:txBody>
+          <a:bodyPr wrap="none">
+            <a:spAutoFit/>
+          </a:bodyPr>
+          <a:lstStyle/>
+          <a:p>
+            <a:r>
+              <a:rPr sz="1100" u="sng">
+                <a:solidFill>
+                  <a:srgbClr val="0066CC"/>
+                </a:solidFill>
+                <a:hlinkClick r:id="rId3"/>
+              </a:rPr>
+              <a:t>📊 Click for interactive version</a:t>
             </a:r>
           </a:p>
         </p:txBody>
@@ -3453,7 +3487,7 @@
         <p:spPr>
           <a:xfrm>
             <a:off x="457200" y="5029200"/>
-            <a:ext cx="8229600" cy="1371600"/>
+            <a:ext cx="8229600" cy="914400"/>
           </a:xfrm>
           <a:prstGeom prst="rect">
             <a:avLst/>
@@ -3475,6 +3509,40 @@
             </a:pPr>
             <a:r>
               <a:t>Waterfall showing margin evolution from FY2022 baseline. Green bars = improvement, red bars = deterioration.</a:t>
+            </a:r>
+          </a:p>
+        </p:txBody>
+      </p:sp>
+      <p:sp>
+        <p:nvSpPr>
+          <p:cNvPr id="5" name="TextBox 4"/>
+          <p:cNvSpPr txBox="1"/>
+          <p:nvPr/>
+        </p:nvSpPr>
+        <p:spPr>
+          <a:xfrm>
+            <a:off x="457200" y="6035040"/>
+            <a:ext cx="8229600" cy="365760"/>
+          </a:xfrm>
+          <a:prstGeom prst="rect">
+            <a:avLst/>
+          </a:prstGeom>
+          <a:noFill/>
+        </p:spPr>
+        <p:txBody>
+          <a:bodyPr wrap="none">
+            <a:spAutoFit/>
+          </a:bodyPr>
+          <a:lstStyle/>
+          <a:p>
+            <a:r>
+              <a:rPr sz="1100" u="sng">
+                <a:solidFill>
+                  <a:srgbClr val="0066CC"/>
+                </a:solidFill>
+                <a:hlinkClick r:id="rId3"/>
+              </a:rPr>
+              <a:t>📊 Click for interactive version</a:t>
             </a:r>
           </a:p>
         </p:txBody>
@@ -3565,7 +3633,7 @@
         <p:spPr>
           <a:xfrm>
             <a:off x="457200" y="5029200"/>
-            <a:ext cx="8229600" cy="1371600"/>
+            <a:ext cx="8229600" cy="914400"/>
           </a:xfrm>
           <a:prstGeom prst="rect">
             <a:avLst/>
@@ -3587,6 +3655,40 @@
             </a:pPr>
             <a:r>
               <a:t>100% stacked bars showing cost structure. Watch for SG&amp;A creep eating into margins.</a:t>
+            </a:r>
+          </a:p>
+        </p:txBody>
+      </p:sp>
+      <p:sp>
+        <p:nvSpPr>
+          <p:cNvPr id="5" name="TextBox 4"/>
+          <p:cNvSpPr txBox="1"/>
+          <p:nvPr/>
+        </p:nvSpPr>
+        <p:spPr>
+          <a:xfrm>
+            <a:off x="457200" y="6035040"/>
+            <a:ext cx="8229600" cy="365760"/>
+          </a:xfrm>
+          <a:prstGeom prst="rect">
+            <a:avLst/>
+          </a:prstGeom>
+          <a:noFill/>
+        </p:spPr>
+        <p:txBody>
+          <a:bodyPr wrap="none">
+            <a:spAutoFit/>
+          </a:bodyPr>
+          <a:lstStyle/>
+          <a:p>
+            <a:r>
+              <a:rPr sz="1100" u="sng">
+                <a:solidFill>
+                  <a:srgbClr val="0066CC"/>
+                </a:solidFill>
+                <a:hlinkClick r:id="rId3"/>
+              </a:rPr>
+              <a:t>📊 Click for interactive version</a:t>
             </a:r>
           </a:p>
         </p:txBody>
@@ -3677,7 +3779,7 @@
         <p:spPr>
           <a:xfrm>
             <a:off x="457200" y="5029200"/>
-            <a:ext cx="8229600" cy="1371600"/>
+            <a:ext cx="8229600" cy="914400"/>
           </a:xfrm>
           <a:prstGeom prst="rect">
             <a:avLst/>
@@ -3699,6 +3801,40 @@
             </a:pPr>
             <a:r>
               <a:t>Shows how revenue flows to EBITDA through operating expenses. The D&amp;A add-back reveals capital intensity.</a:t>
+            </a:r>
+          </a:p>
+        </p:txBody>
+      </p:sp>
+      <p:sp>
+        <p:nvSpPr>
+          <p:cNvPr id="5" name="TextBox 4"/>
+          <p:cNvSpPr txBox="1"/>
+          <p:nvPr/>
+        </p:nvSpPr>
+        <p:spPr>
+          <a:xfrm>
+            <a:off x="457200" y="6035040"/>
+            <a:ext cx="8229600" cy="365760"/>
+          </a:xfrm>
+          <a:prstGeom prst="rect">
+            <a:avLst/>
+          </a:prstGeom>
+          <a:noFill/>
+        </p:spPr>
+        <p:txBody>
+          <a:bodyPr wrap="none">
+            <a:spAutoFit/>
+          </a:bodyPr>
+          <a:lstStyle/>
+          <a:p>
+            <a:r>
+              <a:rPr sz="1100" u="sng">
+                <a:solidFill>
+                  <a:srgbClr val="0066CC"/>
+                </a:solidFill>
+                <a:hlinkClick r:id="rId3"/>
+              </a:rPr>
+              <a:t>📊 Click for interactive version</a:t>
             </a:r>
           </a:p>
         </p:txBody>
@@ -3789,7 +3925,7 @@
         <p:spPr>
           <a:xfrm>
             <a:off x="457200" y="5029200"/>
-            <a:ext cx="8229600" cy="1371600"/>
+            <a:ext cx="8229600" cy="914400"/>
           </a:xfrm>
           <a:prstGeom prst="rect">
             <a:avLst/>
@@ -3811,6 +3947,40 @@
             </a:pPr>
             <a:r>
               <a:t>Quarterly margin changes as waterfall. Identifies seasonal patterns and pressure points.</a:t>
+            </a:r>
+          </a:p>
+        </p:txBody>
+      </p:sp>
+      <p:sp>
+        <p:nvSpPr>
+          <p:cNvPr id="5" name="TextBox 4"/>
+          <p:cNvSpPr txBox="1"/>
+          <p:nvPr/>
+        </p:nvSpPr>
+        <p:spPr>
+          <a:xfrm>
+            <a:off x="457200" y="6035040"/>
+            <a:ext cx="8229600" cy="365760"/>
+          </a:xfrm>
+          <a:prstGeom prst="rect">
+            <a:avLst/>
+          </a:prstGeom>
+          <a:noFill/>
+        </p:spPr>
+        <p:txBody>
+          <a:bodyPr wrap="none">
+            <a:spAutoFit/>
+          </a:bodyPr>
+          <a:lstStyle/>
+          <a:p>
+            <a:r>
+              <a:rPr sz="1100" u="sng">
+                <a:solidFill>
+                  <a:srgbClr val="0066CC"/>
+                </a:solidFill>
+                <a:hlinkClick r:id="rId3"/>
+              </a:rPr>
+              <a:t>📊 Click for interactive version</a:t>
             </a:r>
           </a:p>
         </p:txBody>
@@ -3901,7 +4071,7 @@
         <p:spPr>
           <a:xfrm>
             <a:off x="457200" y="5029200"/>
-            <a:ext cx="8229600" cy="1371600"/>
+            <a:ext cx="8229600" cy="914400"/>
           </a:xfrm>
           <a:prstGeom prst="rect">
             <a:avLst/>
@@ -3923,6 +4093,40 @@
             </a:pPr>
             <a:r>
               <a:t>Compares Net Income to Operating Cash Flow. High-quality earnings convert to cash consistently.</a:t>
+            </a:r>
+          </a:p>
+        </p:txBody>
+      </p:sp>
+      <p:sp>
+        <p:nvSpPr>
+          <p:cNvPr id="5" name="TextBox 4"/>
+          <p:cNvSpPr txBox="1"/>
+          <p:nvPr/>
+        </p:nvSpPr>
+        <p:spPr>
+          <a:xfrm>
+            <a:off x="457200" y="6035040"/>
+            <a:ext cx="8229600" cy="365760"/>
+          </a:xfrm>
+          <a:prstGeom prst="rect">
+            <a:avLst/>
+          </a:prstGeom>
+          <a:noFill/>
+        </p:spPr>
+        <p:txBody>
+          <a:bodyPr wrap="none">
+            <a:spAutoFit/>
+          </a:bodyPr>
+          <a:lstStyle/>
+          <a:p>
+            <a:r>
+              <a:rPr sz="1100" u="sng">
+                <a:solidFill>
+                  <a:srgbClr val="0066CC"/>
+                </a:solidFill>
+                <a:hlinkClick r:id="rId3"/>
+              </a:rPr>
+              <a:t>📊 Click for interactive version</a:t>
             </a:r>
           </a:p>
         </p:txBody>
@@ -4181,7 +4385,7 @@
         <p:spPr>
           <a:xfrm>
             <a:off x="457200" y="5029200"/>
-            <a:ext cx="8229600" cy="1371600"/>
+            <a:ext cx="8229600" cy="914400"/>
           </a:xfrm>
           <a:prstGeom prst="rect">
             <a:avLst/>
@@ -4203,6 +4407,40 @@
             </a:pPr>
             <a:r>
               <a:t>Measures short-term liquidity. Below 1.0 is warning (liabilities exceed assets); above 1.5 is healthy for retail.</a:t>
+            </a:r>
+          </a:p>
+        </p:txBody>
+      </p:sp>
+      <p:sp>
+        <p:nvSpPr>
+          <p:cNvPr id="5" name="TextBox 4"/>
+          <p:cNvSpPr txBox="1"/>
+          <p:nvPr/>
+        </p:nvSpPr>
+        <p:spPr>
+          <a:xfrm>
+            <a:off x="457200" y="6035040"/>
+            <a:ext cx="8229600" cy="365760"/>
+          </a:xfrm>
+          <a:prstGeom prst="rect">
+            <a:avLst/>
+          </a:prstGeom>
+          <a:noFill/>
+        </p:spPr>
+        <p:txBody>
+          <a:bodyPr wrap="none">
+            <a:spAutoFit/>
+          </a:bodyPr>
+          <a:lstStyle/>
+          <a:p>
+            <a:r>
+              <a:rPr sz="1100" u="sng">
+                <a:solidFill>
+                  <a:srgbClr val="0066CC"/>
+                </a:solidFill>
+                <a:hlinkClick r:id="rId3"/>
+              </a:rPr>
+              <a:t>📊 Click for interactive version</a:t>
             </a:r>
           </a:p>
         </p:txBody>
@@ -4293,7 +4531,7 @@
         <p:spPr>
           <a:xfrm>
             <a:off x="457200" y="5029200"/>
-            <a:ext cx="8229600" cy="1371600"/>
+            <a:ext cx="8229600" cy="914400"/>
           </a:xfrm>
           <a:prstGeom prst="rect">
             <a:avLst/>
@@ -4315,6 +4553,40 @@
             </a:pPr>
             <a:r>
               <a:t>Shows debt vs equity mix. Higher debt = higher risk but potentially higher returns on equity.</a:t>
+            </a:r>
+          </a:p>
+        </p:txBody>
+      </p:sp>
+      <p:sp>
+        <p:nvSpPr>
+          <p:cNvPr id="5" name="TextBox 4"/>
+          <p:cNvSpPr txBox="1"/>
+          <p:nvPr/>
+        </p:nvSpPr>
+        <p:spPr>
+          <a:xfrm>
+            <a:off x="457200" y="6035040"/>
+            <a:ext cx="8229600" cy="365760"/>
+          </a:xfrm>
+          <a:prstGeom prst="rect">
+            <a:avLst/>
+          </a:prstGeom>
+          <a:noFill/>
+        </p:spPr>
+        <p:txBody>
+          <a:bodyPr wrap="none">
+            <a:spAutoFit/>
+          </a:bodyPr>
+          <a:lstStyle/>
+          <a:p>
+            <a:r>
+              <a:rPr sz="1100" u="sng">
+                <a:solidFill>
+                  <a:srgbClr val="0066CC"/>
+                </a:solidFill>
+                <a:hlinkClick r:id="rId3"/>
+              </a:rPr>
+              <a:t>📊 Click for interactive version</a:t>
             </a:r>
           </a:p>
         </p:txBody>
@@ -4405,7 +4677,7 @@
         <p:spPr>
           <a:xfrm>
             <a:off x="457200" y="5029200"/>
-            <a:ext cx="8229600" cy="1371600"/>
+            <a:ext cx="8229600" cy="914400"/>
           </a:xfrm>
           <a:prstGeom prst="rect">
             <a:avLst/>
@@ -4427,6 +4699,40 @@
             </a:pPr>
             <a:r>
               <a:t>Key leverage metric showing how many years of earnings to repay debt. Below 3x is healthy; above 5x is risky.</a:t>
+            </a:r>
+          </a:p>
+        </p:txBody>
+      </p:sp>
+      <p:sp>
+        <p:nvSpPr>
+          <p:cNvPr id="5" name="TextBox 4"/>
+          <p:cNvSpPr txBox="1"/>
+          <p:nvPr/>
+        </p:nvSpPr>
+        <p:spPr>
+          <a:xfrm>
+            <a:off x="457200" y="6035040"/>
+            <a:ext cx="8229600" cy="365760"/>
+          </a:xfrm>
+          <a:prstGeom prst="rect">
+            <a:avLst/>
+          </a:prstGeom>
+          <a:noFill/>
+        </p:spPr>
+        <p:txBody>
+          <a:bodyPr wrap="none">
+            <a:spAutoFit/>
+          </a:bodyPr>
+          <a:lstStyle/>
+          <a:p>
+            <a:r>
+              <a:rPr sz="1100" u="sng">
+                <a:solidFill>
+                  <a:srgbClr val="0066CC"/>
+                </a:solidFill>
+                <a:hlinkClick r:id="rId3"/>
+              </a:rPr>
+              <a:t>📊 Click for interactive version</a:t>
             </a:r>
           </a:p>
         </p:txBody>
@@ -4781,7 +5087,7 @@
         <p:spPr>
           <a:xfrm>
             <a:off x="457200" y="5029200"/>
-            <a:ext cx="8229600" cy="1371600"/>
+            <a:ext cx="8229600" cy="914400"/>
           </a:xfrm>
           <a:prstGeom prst="rect">
             <a:avLst/>
@@ -4803,6 +5109,40 @@
             </a:pPr>
             <a:r>
               <a:t>Interest coverage ratio tracking. Above 3x is comfortable; below 2x requires monitoring.</a:t>
+            </a:r>
+          </a:p>
+        </p:txBody>
+      </p:sp>
+      <p:sp>
+        <p:nvSpPr>
+          <p:cNvPr id="5" name="TextBox 4"/>
+          <p:cNvSpPr txBox="1"/>
+          <p:nvPr/>
+        </p:nvSpPr>
+        <p:spPr>
+          <a:xfrm>
+            <a:off x="457200" y="6035040"/>
+            <a:ext cx="8229600" cy="365760"/>
+          </a:xfrm>
+          <a:prstGeom prst="rect">
+            <a:avLst/>
+          </a:prstGeom>
+          <a:noFill/>
+        </p:spPr>
+        <p:txBody>
+          <a:bodyPr wrap="none">
+            <a:spAutoFit/>
+          </a:bodyPr>
+          <a:lstStyle/>
+          <a:p>
+            <a:r>
+              <a:rPr sz="1100" u="sng">
+                <a:solidFill>
+                  <a:srgbClr val="0066CC"/>
+                </a:solidFill>
+                <a:hlinkClick r:id="rId3"/>
+              </a:rPr>
+              <a:t>📊 Click for interactive version</a:t>
             </a:r>
           </a:p>
         </p:txBody>
@@ -4893,7 +5233,7 @@
         <p:spPr>
           <a:xfrm>
             <a:off x="457200" y="5029200"/>
-            <a:ext cx="8229600" cy="1371600"/>
+            <a:ext cx="8229600" cy="914400"/>
           </a:xfrm>
           <a:prstGeom prst="rect">
             <a:avLst/>
@@ -4915,6 +5255,40 @@
             </a:pPr>
             <a:r>
               <a:t>Three cash flow lines: Operating, Investing, Financing. Operating should be consistently positive.</a:t>
+            </a:r>
+          </a:p>
+        </p:txBody>
+      </p:sp>
+      <p:sp>
+        <p:nvSpPr>
+          <p:cNvPr id="5" name="TextBox 4"/>
+          <p:cNvSpPr txBox="1"/>
+          <p:nvPr/>
+        </p:nvSpPr>
+        <p:spPr>
+          <a:xfrm>
+            <a:off x="457200" y="6035040"/>
+            <a:ext cx="8229600" cy="365760"/>
+          </a:xfrm>
+          <a:prstGeom prst="rect">
+            <a:avLst/>
+          </a:prstGeom>
+          <a:noFill/>
+        </p:spPr>
+        <p:txBody>
+          <a:bodyPr wrap="none">
+            <a:spAutoFit/>
+          </a:bodyPr>
+          <a:lstStyle/>
+          <a:p>
+            <a:r>
+              <a:rPr sz="1100" u="sng">
+                <a:solidFill>
+                  <a:srgbClr val="0066CC"/>
+                </a:solidFill>
+                <a:hlinkClick r:id="rId3"/>
+              </a:rPr>
+              <a:t>📊 Click for interactive version</a:t>
             </a:r>
           </a:p>
         </p:txBody>
@@ -5173,7 +5547,7 @@
         <p:spPr>
           <a:xfrm>
             <a:off x="457200" y="5029200"/>
-            <a:ext cx="8229600" cy="1371600"/>
+            <a:ext cx="8229600" cy="914400"/>
           </a:xfrm>
           <a:prstGeom prst="rect">
             <a:avLst/>
@@ -5195,6 +5569,40 @@
             </a:pPr>
             <a:r>
               <a:t>Decomposes ROE into Profit Margin x Asset Turnover x Financial Leverage. Shows what drives returns.</a:t>
+            </a:r>
+          </a:p>
+        </p:txBody>
+      </p:sp>
+      <p:sp>
+        <p:nvSpPr>
+          <p:cNvPr id="5" name="TextBox 4"/>
+          <p:cNvSpPr txBox="1"/>
+          <p:nvPr/>
+        </p:nvSpPr>
+        <p:spPr>
+          <a:xfrm>
+            <a:off x="457200" y="6035040"/>
+            <a:ext cx="8229600" cy="365760"/>
+          </a:xfrm>
+          <a:prstGeom prst="rect">
+            <a:avLst/>
+          </a:prstGeom>
+          <a:noFill/>
+        </p:spPr>
+        <p:txBody>
+          <a:bodyPr wrap="none">
+            <a:spAutoFit/>
+          </a:bodyPr>
+          <a:lstStyle/>
+          <a:p>
+            <a:r>
+              <a:rPr sz="1100" u="sng">
+                <a:solidFill>
+                  <a:srgbClr val="0066CC"/>
+                </a:solidFill>
+                <a:hlinkClick r:id="rId3"/>
+              </a:rPr>
+              <a:t>📊 Click for interactive version</a:t>
             </a:r>
           </a:p>
         </p:txBody>
@@ -5285,7 +5693,7 @@
         <p:spPr>
           <a:xfrm>
             <a:off x="457200" y="5029200"/>
-            <a:ext cx="8229600" cy="1371600"/>
+            <a:ext cx="8229600" cy="914400"/>
           </a:xfrm>
           <a:prstGeom prst="rect">
             <a:avLst/>
@@ -5307,6 +5715,40 @@
             </a:pPr>
             <a:r>
               <a:t>Tracks turnover ratio and days on hand. Faster turns = less capital tied up in inventory.</a:t>
+            </a:r>
+          </a:p>
+        </p:txBody>
+      </p:sp>
+      <p:sp>
+        <p:nvSpPr>
+          <p:cNvPr id="5" name="TextBox 4"/>
+          <p:cNvSpPr txBox="1"/>
+          <p:nvPr/>
+        </p:nvSpPr>
+        <p:spPr>
+          <a:xfrm>
+            <a:off x="457200" y="6035040"/>
+            <a:ext cx="8229600" cy="365760"/>
+          </a:xfrm>
+          <a:prstGeom prst="rect">
+            <a:avLst/>
+          </a:prstGeom>
+          <a:noFill/>
+        </p:spPr>
+        <p:txBody>
+          <a:bodyPr wrap="none">
+            <a:spAutoFit/>
+          </a:bodyPr>
+          <a:lstStyle/>
+          <a:p>
+            <a:r>
+              <a:rPr sz="1100" u="sng">
+                <a:solidFill>
+                  <a:srgbClr val="0066CC"/>
+                </a:solidFill>
+                <a:hlinkClick r:id="rId3"/>
+              </a:rPr>
+              <a:t>📊 Click for interactive version</a:t>
             </a:r>
           </a:p>
         </p:txBody>
@@ -5397,7 +5839,7 @@
         <p:spPr>
           <a:xfrm>
             <a:off x="457200" y="5029200"/>
-            <a:ext cx="8229600" cy="1371600"/>
+            <a:ext cx="8229600" cy="914400"/>
           </a:xfrm>
           <a:prstGeom prst="rect">
             <a:avLst/>
@@ -5419,6 +5861,40 @@
             </a:pPr>
             <a:r>
               <a:t>Days to convert inventory to cash vs retail peers. Lower is better; negative means suppliers finance operations.</a:t>
+            </a:r>
+          </a:p>
+        </p:txBody>
+      </p:sp>
+      <p:sp>
+        <p:nvSpPr>
+          <p:cNvPr id="5" name="TextBox 4"/>
+          <p:cNvSpPr txBox="1"/>
+          <p:nvPr/>
+        </p:nvSpPr>
+        <p:spPr>
+          <a:xfrm>
+            <a:off x="457200" y="6035040"/>
+            <a:ext cx="8229600" cy="365760"/>
+          </a:xfrm>
+          <a:prstGeom prst="rect">
+            <a:avLst/>
+          </a:prstGeom>
+          <a:noFill/>
+        </p:spPr>
+        <p:txBody>
+          <a:bodyPr wrap="none">
+            <a:spAutoFit/>
+          </a:bodyPr>
+          <a:lstStyle/>
+          <a:p>
+            <a:r>
+              <a:rPr sz="1100" u="sng">
+                <a:solidFill>
+                  <a:srgbClr val="0066CC"/>
+                </a:solidFill>
+                <a:hlinkClick r:id="rId3"/>
+              </a:rPr>
+              <a:t>📊 Click for interactive version</a:t>
             </a:r>
           </a:p>
         </p:txBody>
@@ -5509,7 +5985,7 @@
         <p:spPr>
           <a:xfrm>
             <a:off x="457200" y="5029200"/>
-            <a:ext cx="8229600" cy="1371600"/>
+            <a:ext cx="8229600" cy="914400"/>
           </a:xfrm>
           <a:prstGeom prst="rect">
             <a:avLst/>
@@ -5531,6 +6007,40 @@
             </a:pPr>
             <a:r>
               <a:t>Operating cash vs capital spending. The gap between them is Free Cash Flow available for shareholders.</a:t>
+            </a:r>
+          </a:p>
+        </p:txBody>
+      </p:sp>
+      <p:sp>
+        <p:nvSpPr>
+          <p:cNvPr id="5" name="TextBox 4"/>
+          <p:cNvSpPr txBox="1"/>
+          <p:nvPr/>
+        </p:nvSpPr>
+        <p:spPr>
+          <a:xfrm>
+            <a:off x="457200" y="6035040"/>
+            <a:ext cx="8229600" cy="365760"/>
+          </a:xfrm>
+          <a:prstGeom prst="rect">
+            <a:avLst/>
+          </a:prstGeom>
+          <a:noFill/>
+        </p:spPr>
+        <p:txBody>
+          <a:bodyPr wrap="none">
+            <a:spAutoFit/>
+          </a:bodyPr>
+          <a:lstStyle/>
+          <a:p>
+            <a:r>
+              <a:rPr sz="1100" u="sng">
+                <a:solidFill>
+                  <a:srgbClr val="0066CC"/>
+                </a:solidFill>
+                <a:hlinkClick r:id="rId3"/>
+              </a:rPr>
+              <a:t>📊 Click for interactive version</a:t>
             </a:r>
           </a:p>
         </p:txBody>
@@ -5789,7 +6299,7 @@
         <p:spPr>
           <a:xfrm>
             <a:off x="457200" y="5029200"/>
-            <a:ext cx="8229600" cy="1371600"/>
+            <a:ext cx="8229600" cy="914400"/>
           </a:xfrm>
           <a:prstGeom prst="rect">
             <a:avLst/>
@@ -5811,6 +6321,40 @@
             </a:pPr>
             <a:r>
               <a:t>P/E ratio vs revenue growth for Target and peers. Lower-right quadrant = undervalued opportunities.</a:t>
+            </a:r>
+          </a:p>
+        </p:txBody>
+      </p:sp>
+      <p:sp>
+        <p:nvSpPr>
+          <p:cNvPr id="5" name="TextBox 4"/>
+          <p:cNvSpPr txBox="1"/>
+          <p:nvPr/>
+        </p:nvSpPr>
+        <p:spPr>
+          <a:xfrm>
+            <a:off x="457200" y="6035040"/>
+            <a:ext cx="8229600" cy="365760"/>
+          </a:xfrm>
+          <a:prstGeom prst="rect">
+            <a:avLst/>
+          </a:prstGeom>
+          <a:noFill/>
+        </p:spPr>
+        <p:txBody>
+          <a:bodyPr wrap="none">
+            <a:spAutoFit/>
+          </a:bodyPr>
+          <a:lstStyle/>
+          <a:p>
+            <a:r>
+              <a:rPr sz="1100" u="sng">
+                <a:solidFill>
+                  <a:srgbClr val="0066CC"/>
+                </a:solidFill>
+                <a:hlinkClick r:id="rId3"/>
+              </a:rPr>
+              <a:t>📊 Click for interactive version</a:t>
             </a:r>
           </a:p>
         </p:txBody>
@@ -5901,7 +6445,7 @@
         <p:spPr>
           <a:xfrm>
             <a:off x="457200" y="5029200"/>
-            <a:ext cx="8229600" cy="1371600"/>
+            <a:ext cx="8229600" cy="914400"/>
           </a:xfrm>
           <a:prstGeom prst="rect">
             <a:avLst/>
@@ -5923,6 +6467,40 @@
             </a:pPr>
             <a:r>
               <a:t>Current price vs historical valuation range. Below 25th percentile = historically undervalued.</a:t>
+            </a:r>
+          </a:p>
+        </p:txBody>
+      </p:sp>
+      <p:sp>
+        <p:nvSpPr>
+          <p:cNvPr id="5" name="TextBox 4"/>
+          <p:cNvSpPr txBox="1"/>
+          <p:nvPr/>
+        </p:nvSpPr>
+        <p:spPr>
+          <a:xfrm>
+            <a:off x="457200" y="6035040"/>
+            <a:ext cx="8229600" cy="365760"/>
+          </a:xfrm>
+          <a:prstGeom prst="rect">
+            <a:avLst/>
+          </a:prstGeom>
+          <a:noFill/>
+        </p:spPr>
+        <p:txBody>
+          <a:bodyPr wrap="none">
+            <a:spAutoFit/>
+          </a:bodyPr>
+          <a:lstStyle/>
+          <a:p>
+            <a:r>
+              <a:rPr sz="1100" u="sng">
+                <a:solidFill>
+                  <a:srgbClr val="0066CC"/>
+                </a:solidFill>
+                <a:hlinkClick r:id="rId3"/>
+              </a:rPr>
+              <a:t>📊 Click for interactive version</a:t>
             </a:r>
           </a:p>
         </p:txBody>
@@ -6218,7 +6796,7 @@
         <p:spPr>
           <a:xfrm>
             <a:off x="457200" y="5029200"/>
-            <a:ext cx="8229600" cy="1371600"/>
+            <a:ext cx="8229600" cy="914400"/>
           </a:xfrm>
           <a:prstGeom prst="rect">
             <a:avLst/>
@@ -6240,6 +6818,40 @@
             </a:pPr>
             <a:r>
               <a:t>Visualizes cash allocation: CapEx, dividends, buybacks, debt repayment. Shows management priorities.</a:t>
+            </a:r>
+          </a:p>
+        </p:txBody>
+      </p:sp>
+      <p:sp>
+        <p:nvSpPr>
+          <p:cNvPr id="5" name="TextBox 4"/>
+          <p:cNvSpPr txBox="1"/>
+          <p:nvPr/>
+        </p:nvSpPr>
+        <p:spPr>
+          <a:xfrm>
+            <a:off x="457200" y="6035040"/>
+            <a:ext cx="8229600" cy="365760"/>
+          </a:xfrm>
+          <a:prstGeom prst="rect">
+            <a:avLst/>
+          </a:prstGeom>
+          <a:noFill/>
+        </p:spPr>
+        <p:txBody>
+          <a:bodyPr wrap="none">
+            <a:spAutoFit/>
+          </a:bodyPr>
+          <a:lstStyle/>
+          <a:p>
+            <a:r>
+              <a:rPr sz="1100" u="sng">
+                <a:solidFill>
+                  <a:srgbClr val="0066CC"/>
+                </a:solidFill>
+                <a:hlinkClick r:id="rId3"/>
+              </a:rPr>
+              <a:t>📊 Click for interactive version</a:t>
             </a:r>
           </a:p>
         </p:txBody>
@@ -6330,7 +6942,7 @@
         <p:spPr>
           <a:xfrm>
             <a:off x="457200" y="5029200"/>
-            <a:ext cx="8229600" cy="1371600"/>
+            <a:ext cx="8229600" cy="914400"/>
           </a:xfrm>
           <a:prstGeom prst="rect">
             <a:avLst/>
@@ -6352,6 +6964,40 @@
             </a:pPr>
             <a:r>
               <a:t>Stacked area of risk mentions (shrink, theft, markdown) over time. Rising trends signal increasing concerns.</a:t>
+            </a:r>
+          </a:p>
+        </p:txBody>
+      </p:sp>
+      <p:sp>
+        <p:nvSpPr>
+          <p:cNvPr id="5" name="TextBox 4"/>
+          <p:cNvSpPr txBox="1"/>
+          <p:nvPr/>
+        </p:nvSpPr>
+        <p:spPr>
+          <a:xfrm>
+            <a:off x="457200" y="6035040"/>
+            <a:ext cx="8229600" cy="365760"/>
+          </a:xfrm>
+          <a:prstGeom prst="rect">
+            <a:avLst/>
+          </a:prstGeom>
+          <a:noFill/>
+        </p:spPr>
+        <p:txBody>
+          <a:bodyPr wrap="none">
+            <a:spAutoFit/>
+          </a:bodyPr>
+          <a:lstStyle/>
+          <a:p>
+            <a:r>
+              <a:rPr sz="1100" u="sng">
+                <a:solidFill>
+                  <a:srgbClr val="0066CC"/>
+                </a:solidFill>
+                <a:hlinkClick r:id="rId3"/>
+              </a:rPr>
+              <a:t>📊 Click for interactive version</a:t>
             </a:r>
           </a:p>
         </p:txBody>
@@ -6442,7 +7088,7 @@
         <p:spPr>
           <a:xfrm>
             <a:off x="457200" y="5029200"/>
-            <a:ext cx="8229600" cy="1371600"/>
+            <a:ext cx="8229600" cy="914400"/>
           </a:xfrm>
           <a:prstGeom prst="rect">
             <a:avLst/>
@@ -6464,6 +7110,40 @@
             </a:pPr>
             <a:r>
               <a:t>Intensity grid showing risk types by period. Dark cells = high concern in that area.</a:t>
+            </a:r>
+          </a:p>
+        </p:txBody>
+      </p:sp>
+      <p:sp>
+        <p:nvSpPr>
+          <p:cNvPr id="5" name="TextBox 4"/>
+          <p:cNvSpPr txBox="1"/>
+          <p:nvPr/>
+        </p:nvSpPr>
+        <p:spPr>
+          <a:xfrm>
+            <a:off x="457200" y="6035040"/>
+            <a:ext cx="8229600" cy="365760"/>
+          </a:xfrm>
+          <a:prstGeom prst="rect">
+            <a:avLst/>
+          </a:prstGeom>
+          <a:noFill/>
+        </p:spPr>
+        <p:txBody>
+          <a:bodyPr wrap="none">
+            <a:spAutoFit/>
+          </a:bodyPr>
+          <a:lstStyle/>
+          <a:p>
+            <a:r>
+              <a:rPr sz="1100" u="sng">
+                <a:solidFill>
+                  <a:srgbClr val="0066CC"/>
+                </a:solidFill>
+                <a:hlinkClick r:id="rId3"/>
+              </a:rPr>
+              <a:t>📊 Click for interactive version</a:t>
             </a:r>
           </a:p>
         </p:txBody>
@@ -6722,7 +7402,7 @@
         <p:spPr>
           <a:xfrm>
             <a:off x="457200" y="5029200"/>
-            <a:ext cx="8229600" cy="1371600"/>
+            <a:ext cx="8229600" cy="914400"/>
           </a:xfrm>
           <a:prstGeom prst="rect">
             <a:avLst/>
@@ -6744,6 +7424,40 @@
             </a:pPr>
             <a:r>
               <a:t>Shows Target's 10-year revenue and net income trajectory from annual 10-K filings. Look for consistent growth and whether profits keep pace with revenue.</a:t>
+            </a:r>
+          </a:p>
+        </p:txBody>
+      </p:sp>
+      <p:sp>
+        <p:nvSpPr>
+          <p:cNvPr id="5" name="TextBox 4"/>
+          <p:cNvSpPr txBox="1"/>
+          <p:nvPr/>
+        </p:nvSpPr>
+        <p:spPr>
+          <a:xfrm>
+            <a:off x="457200" y="6035040"/>
+            <a:ext cx="8229600" cy="365760"/>
+          </a:xfrm>
+          <a:prstGeom prst="rect">
+            <a:avLst/>
+          </a:prstGeom>
+          <a:noFill/>
+        </p:spPr>
+        <p:txBody>
+          <a:bodyPr wrap="none">
+            <a:spAutoFit/>
+          </a:bodyPr>
+          <a:lstStyle/>
+          <a:p>
+            <a:r>
+              <a:rPr sz="1100" u="sng">
+                <a:solidFill>
+                  <a:srgbClr val="0066CC"/>
+                </a:solidFill>
+                <a:hlinkClick r:id="rId3"/>
+              </a:rPr>
+              <a:t>📊 Click for interactive version</a:t>
             </a:r>
           </a:p>
         </p:txBody>
@@ -6834,7 +7548,7 @@
         <p:spPr>
           <a:xfrm>
             <a:off x="457200" y="5029200"/>
-            <a:ext cx="8229600" cy="1371600"/>
+            <a:ext cx="8229600" cy="914400"/>
           </a:xfrm>
           <a:prstGeom prst="rect">
             <a:avLst/>
@@ -6856,6 +7570,40 @@
             </a:pPr>
             <a:r>
               <a:t>Tracks year-over-year revenue growth rates by quarter. Reveals acceleration or deceleration in growth momentum.</a:t>
+            </a:r>
+          </a:p>
+        </p:txBody>
+      </p:sp>
+      <p:sp>
+        <p:nvSpPr>
+          <p:cNvPr id="5" name="TextBox 4"/>
+          <p:cNvSpPr txBox="1"/>
+          <p:nvPr/>
+        </p:nvSpPr>
+        <p:spPr>
+          <a:xfrm>
+            <a:off x="457200" y="6035040"/>
+            <a:ext cx="8229600" cy="365760"/>
+          </a:xfrm>
+          <a:prstGeom prst="rect">
+            <a:avLst/>
+          </a:prstGeom>
+          <a:noFill/>
+        </p:spPr>
+        <p:txBody>
+          <a:bodyPr wrap="none">
+            <a:spAutoFit/>
+          </a:bodyPr>
+          <a:lstStyle/>
+          <a:p>
+            <a:r>
+              <a:rPr sz="1100" u="sng">
+                <a:solidFill>
+                  <a:srgbClr val="0066CC"/>
+                </a:solidFill>
+                <a:hlinkClick r:id="rId3"/>
+              </a:rPr>
+              <a:t>📊 Click for interactive version</a:t>
             </a:r>
           </a:p>
         </p:txBody>
@@ -6946,7 +7694,7 @@
         <p:spPr>
           <a:xfrm>
             <a:off x="457200" y="5029200"/>
-            <a:ext cx="8229600" cy="1371600"/>
+            <a:ext cx="8229600" cy="914400"/>
           </a:xfrm>
           <a:prstGeom prst="rect">
             <a:avLst/>
@@ -6968,6 +7716,40 @@
             </a:pPr>
             <a:r>
               <a:t>Compares revenue growth to inventory buildup. Inventory growing faster than sales signals potential markdown risk.</a:t>
+            </a:r>
+          </a:p>
+        </p:txBody>
+      </p:sp>
+      <p:sp>
+        <p:nvSpPr>
+          <p:cNvPr id="5" name="TextBox 4"/>
+          <p:cNvSpPr txBox="1"/>
+          <p:nvPr/>
+        </p:nvSpPr>
+        <p:spPr>
+          <a:xfrm>
+            <a:off x="457200" y="6035040"/>
+            <a:ext cx="8229600" cy="365760"/>
+          </a:xfrm>
+          <a:prstGeom prst="rect">
+            <a:avLst/>
+          </a:prstGeom>
+          <a:noFill/>
+        </p:spPr>
+        <p:txBody>
+          <a:bodyPr wrap="none">
+            <a:spAutoFit/>
+          </a:bodyPr>
+          <a:lstStyle/>
+          <a:p>
+            <a:r>
+              <a:rPr sz="1100" u="sng">
+                <a:solidFill>
+                  <a:srgbClr val="0066CC"/>
+                </a:solidFill>
+                <a:hlinkClick r:id="rId3"/>
+              </a:rPr>
+              <a:t>📊 Click for interactive version</a:t>
             </a:r>
           </a:p>
         </p:txBody>
@@ -7058,7 +7840,7 @@
         <p:spPr>
           <a:xfrm>
             <a:off x="457200" y="5029200"/>
-            <a:ext cx="8229600" cy="1371600"/>
+            <a:ext cx="8229600" cy="914400"/>
           </a:xfrm>
           <a:prstGeom prst="rect">
             <a:avLst/>
@@ -7080,6 +7862,40 @@
             </a:pPr>
             <a:r>
               <a:t>Quarterly view with calculated Q4 data showing seasonal patterns. Q4 (holiday season) typically shows peak revenue.</a:t>
+            </a:r>
+          </a:p>
+        </p:txBody>
+      </p:sp>
+      <p:sp>
+        <p:nvSpPr>
+          <p:cNvPr id="5" name="TextBox 4"/>
+          <p:cNvSpPr txBox="1"/>
+          <p:nvPr/>
+        </p:nvSpPr>
+        <p:spPr>
+          <a:xfrm>
+            <a:off x="457200" y="6035040"/>
+            <a:ext cx="8229600" cy="365760"/>
+          </a:xfrm>
+          <a:prstGeom prst="rect">
+            <a:avLst/>
+          </a:prstGeom>
+          <a:noFill/>
+        </p:spPr>
+        <p:txBody>
+          <a:bodyPr wrap="none">
+            <a:spAutoFit/>
+          </a:bodyPr>
+          <a:lstStyle/>
+          <a:p>
+            <a:r>
+              <a:rPr sz="1100" u="sng">
+                <a:solidFill>
+                  <a:srgbClr val="0066CC"/>
+                </a:solidFill>
+                <a:hlinkClick r:id="rId3"/>
+              </a:rPr>
+              <a:t>📊 Click for interactive version</a:t>
             </a:r>
           </a:p>
         </p:txBody>

</xml_diff>

<commit_message>
Update presentation info icon tooltips and regenerate chart outputs
Fix info icon hyperlinks to use click_action for shape-level clickability
and set tooltip via XML for hover descriptions in slideshow mode. Regenerate
chart HTML/PNG outputs with latest visualization changes.

Co-Authored-By: Claude Opus 4.5 <noreply@anthropic.com>
</commit_message>
<xml_diff>
--- a/output/Target_Financial_Analysis.pptx
+++ b/output/Target_Financial_Analysis.pptx
@@ -3884,7 +3884,9 @@
       </p:sp>
       <p:sp>
         <p:nvSpPr>
-          <p:cNvPr id="3" name="TextBox 2"/>
+          <p:cNvPr id="3" name="TextBox 2">
+            <a:hlinkClick r:id="rId2"/>
+          </p:cNvPr>
           <p:cNvSpPr txBox="1"/>
           <p:nvPr/>
         </p:nvSpPr>
@@ -3909,7 +3911,7 @@
                 <a:solidFill>
                   <a:srgbClr val="646464"/>
                 </a:solidFill>
-                <a:hlinkClick r:id="rId2"/>
+                <a:hlinkClick r:id="rId2" tooltip="Three margin lines tracking profitability over time. Compression between lines reveals where profits leak."/>
               </a:rPr>
               <a:t>ⓘ</a:t>
             </a:r>
@@ -3977,7 +3979,9 @@
       </p:sp>
       <p:sp>
         <p:nvSpPr>
-          <p:cNvPr id="6" name="TextBox 5"/>
+          <p:cNvPr id="6" name="TextBox 5">
+            <a:hlinkClick r:id="rId2"/>
+          </p:cNvPr>
           <p:cNvSpPr txBox="1"/>
           <p:nvPr/>
         </p:nvSpPr>
@@ -4002,7 +4006,6 @@
                 <a:solidFill>
                   <a:srgbClr val="0066CC"/>
                 </a:solidFill>
-                <a:hlinkClick r:id="rId2"/>
               </a:rPr>
               <a:t>📊 Click for interactive version</a:t>
             </a:r>
@@ -4064,7 +4067,9 @@
       </p:sp>
       <p:sp>
         <p:nvSpPr>
-          <p:cNvPr id="3" name="TextBox 2"/>
+          <p:cNvPr id="3" name="TextBox 2">
+            <a:hlinkClick r:id="rId2"/>
+          </p:cNvPr>
           <p:cNvSpPr txBox="1"/>
           <p:nvPr/>
         </p:nvSpPr>
@@ -4089,7 +4094,7 @@
                 <a:solidFill>
                   <a:srgbClr val="646464"/>
                 </a:solidFill>
-                <a:hlinkClick r:id="rId2"/>
+                <a:hlinkClick r:id="rId2" tooltip="Waterfall showing margin evolution from FY2022 baseline. Green bars = improvement, red bars = deterioration."/>
               </a:rPr>
               <a:t>ⓘ</a:t>
             </a:r>
@@ -4157,7 +4162,9 @@
       </p:sp>
       <p:sp>
         <p:nvSpPr>
-          <p:cNvPr id="6" name="TextBox 5"/>
+          <p:cNvPr id="6" name="TextBox 5">
+            <a:hlinkClick r:id="rId2"/>
+          </p:cNvPr>
           <p:cNvSpPr txBox="1"/>
           <p:nvPr/>
         </p:nvSpPr>
@@ -4182,7 +4189,6 @@
                 <a:solidFill>
                   <a:srgbClr val="0066CC"/>
                 </a:solidFill>
-                <a:hlinkClick r:id="rId2"/>
               </a:rPr>
               <a:t>📊 Click for interactive version</a:t>
             </a:r>
@@ -4244,7 +4250,9 @@
       </p:sp>
       <p:sp>
         <p:nvSpPr>
-          <p:cNvPr id="3" name="TextBox 2"/>
+          <p:cNvPr id="3" name="TextBox 2">
+            <a:hlinkClick r:id="rId2"/>
+          </p:cNvPr>
           <p:cNvSpPr txBox="1"/>
           <p:nvPr/>
         </p:nvSpPr>
@@ -4269,7 +4277,7 @@
                 <a:solidFill>
                   <a:srgbClr val="646464"/>
                 </a:solidFill>
-                <a:hlinkClick r:id="rId2"/>
+                <a:hlinkClick r:id="rId2" tooltip="100% stacked bars showing cost structure. Watch for SG&amp;A creep eating into margins."/>
               </a:rPr>
               <a:t>ⓘ</a:t>
             </a:r>
@@ -4337,7 +4345,9 @@
       </p:sp>
       <p:sp>
         <p:nvSpPr>
-          <p:cNvPr id="6" name="TextBox 5"/>
+          <p:cNvPr id="6" name="TextBox 5">
+            <a:hlinkClick r:id="rId2"/>
+          </p:cNvPr>
           <p:cNvSpPr txBox="1"/>
           <p:nvPr/>
         </p:nvSpPr>
@@ -4362,7 +4372,6 @@
                 <a:solidFill>
                   <a:srgbClr val="0066CC"/>
                 </a:solidFill>
-                <a:hlinkClick r:id="rId2"/>
               </a:rPr>
               <a:t>📊 Click for interactive version</a:t>
             </a:r>
@@ -4424,7 +4433,9 @@
       </p:sp>
       <p:sp>
         <p:nvSpPr>
-          <p:cNvPr id="3" name="TextBox 2"/>
+          <p:cNvPr id="3" name="TextBox 2">
+            <a:hlinkClick r:id="rId2"/>
+          </p:cNvPr>
           <p:cNvSpPr txBox="1"/>
           <p:nvPr/>
         </p:nvSpPr>
@@ -4449,7 +4460,7 @@
                 <a:solidFill>
                   <a:srgbClr val="646464"/>
                 </a:solidFill>
-                <a:hlinkClick r:id="rId2"/>
+                <a:hlinkClick r:id="rId2" tooltip="Shows how revenue flows to EBITDA through operating expenses. The D&amp;A add-back reveals capital intensity."/>
               </a:rPr>
               <a:t>ⓘ</a:t>
             </a:r>
@@ -4517,7 +4528,9 @@
       </p:sp>
       <p:sp>
         <p:nvSpPr>
-          <p:cNvPr id="6" name="TextBox 5"/>
+          <p:cNvPr id="6" name="TextBox 5">
+            <a:hlinkClick r:id="rId2"/>
+          </p:cNvPr>
           <p:cNvSpPr txBox="1"/>
           <p:nvPr/>
         </p:nvSpPr>
@@ -4542,7 +4555,6 @@
                 <a:solidFill>
                   <a:srgbClr val="0066CC"/>
                 </a:solidFill>
-                <a:hlinkClick r:id="rId2"/>
               </a:rPr>
               <a:t>📊 Click for interactive version</a:t>
             </a:r>
@@ -4604,7 +4616,9 @@
       </p:sp>
       <p:sp>
         <p:nvSpPr>
-          <p:cNvPr id="3" name="TextBox 2"/>
+          <p:cNvPr id="3" name="TextBox 2">
+            <a:hlinkClick r:id="rId2"/>
+          </p:cNvPr>
           <p:cNvSpPr txBox="1"/>
           <p:nvPr/>
         </p:nvSpPr>
@@ -4629,7 +4643,7 @@
                 <a:solidFill>
                   <a:srgbClr val="646464"/>
                 </a:solidFill>
-                <a:hlinkClick r:id="rId2"/>
+                <a:hlinkClick r:id="rId2" tooltip="Quarterly margin changes as waterfall. Identifies seasonal patterns and pressure points."/>
               </a:rPr>
               <a:t>ⓘ</a:t>
             </a:r>
@@ -4697,7 +4711,9 @@
       </p:sp>
       <p:sp>
         <p:nvSpPr>
-          <p:cNvPr id="6" name="TextBox 5"/>
+          <p:cNvPr id="6" name="TextBox 5">
+            <a:hlinkClick r:id="rId2"/>
+          </p:cNvPr>
           <p:cNvSpPr txBox="1"/>
           <p:nvPr/>
         </p:nvSpPr>
@@ -4722,7 +4738,6 @@
                 <a:solidFill>
                   <a:srgbClr val="0066CC"/>
                 </a:solidFill>
-                <a:hlinkClick r:id="rId2"/>
               </a:rPr>
               <a:t>📊 Click for interactive version</a:t>
             </a:r>
@@ -4784,7 +4799,9 @@
       </p:sp>
       <p:sp>
         <p:nvSpPr>
-          <p:cNvPr id="3" name="TextBox 2"/>
+          <p:cNvPr id="3" name="TextBox 2">
+            <a:hlinkClick r:id="rId2"/>
+          </p:cNvPr>
           <p:cNvSpPr txBox="1"/>
           <p:nvPr/>
         </p:nvSpPr>
@@ -4809,7 +4826,7 @@
                 <a:solidFill>
                   <a:srgbClr val="646464"/>
                 </a:solidFill>
-                <a:hlinkClick r:id="rId2"/>
+                <a:hlinkClick r:id="rId2" tooltip="Compares Net Income to Operating Cash Flow. High-quality earnings convert to cash consistently."/>
               </a:rPr>
               <a:t>ⓘ</a:t>
             </a:r>
@@ -4877,7 +4894,9 @@
       </p:sp>
       <p:sp>
         <p:nvSpPr>
-          <p:cNvPr id="6" name="TextBox 5"/>
+          <p:cNvPr id="6" name="TextBox 5">
+            <a:hlinkClick r:id="rId2"/>
+          </p:cNvPr>
           <p:cNvSpPr txBox="1"/>
           <p:nvPr/>
         </p:nvSpPr>
@@ -4902,7 +4921,6 @@
                 <a:solidFill>
                   <a:srgbClr val="0066CC"/>
                 </a:solidFill>
-                <a:hlinkClick r:id="rId2"/>
               </a:rPr>
               <a:t>📊 Click for interactive version</a:t>
             </a:r>
@@ -5796,7 +5814,9 @@
       </p:sp>
       <p:sp>
         <p:nvSpPr>
-          <p:cNvPr id="3" name="TextBox 2"/>
+          <p:cNvPr id="3" name="TextBox 2">
+            <a:hlinkClick r:id="rId2"/>
+          </p:cNvPr>
           <p:cNvSpPr txBox="1"/>
           <p:nvPr/>
         </p:nvSpPr>
@@ -5821,7 +5841,7 @@
                 <a:solidFill>
                   <a:srgbClr val="646464"/>
                 </a:solidFill>
-                <a:hlinkClick r:id="rId2"/>
+                <a:hlinkClick r:id="rId2" tooltip="Measures short-term liquidity. Below 1.0 is warning (liabilities exceed assets); above 1.5 is healthy for retail."/>
               </a:rPr>
               <a:t>ⓘ</a:t>
             </a:r>
@@ -5889,7 +5909,9 @@
       </p:sp>
       <p:sp>
         <p:nvSpPr>
-          <p:cNvPr id="6" name="TextBox 5"/>
+          <p:cNvPr id="6" name="TextBox 5">
+            <a:hlinkClick r:id="rId2"/>
+          </p:cNvPr>
           <p:cNvSpPr txBox="1"/>
           <p:nvPr/>
         </p:nvSpPr>
@@ -5914,7 +5936,6 @@
                 <a:solidFill>
                   <a:srgbClr val="0066CC"/>
                 </a:solidFill>
-                <a:hlinkClick r:id="rId2"/>
               </a:rPr>
               <a:t>📊 Click for interactive version</a:t>
             </a:r>
@@ -5976,7 +5997,9 @@
       </p:sp>
       <p:sp>
         <p:nvSpPr>
-          <p:cNvPr id="3" name="TextBox 2"/>
+          <p:cNvPr id="3" name="TextBox 2">
+            <a:hlinkClick r:id="rId2"/>
+          </p:cNvPr>
           <p:cNvSpPr txBox="1"/>
           <p:nvPr/>
         </p:nvSpPr>
@@ -6001,7 +6024,7 @@
                 <a:solidFill>
                   <a:srgbClr val="646464"/>
                 </a:solidFill>
-                <a:hlinkClick r:id="rId2"/>
+                <a:hlinkClick r:id="rId2" tooltip="Shows debt vs equity mix. Higher debt = higher risk but potentially higher returns on equity."/>
               </a:rPr>
               <a:t>ⓘ</a:t>
             </a:r>
@@ -6069,7 +6092,9 @@
       </p:sp>
       <p:sp>
         <p:nvSpPr>
-          <p:cNvPr id="6" name="TextBox 5"/>
+          <p:cNvPr id="6" name="TextBox 5">
+            <a:hlinkClick r:id="rId2"/>
+          </p:cNvPr>
           <p:cNvSpPr txBox="1"/>
           <p:nvPr/>
         </p:nvSpPr>
@@ -6094,7 +6119,6 @@
                 <a:solidFill>
                   <a:srgbClr val="0066CC"/>
                 </a:solidFill>
-                <a:hlinkClick r:id="rId2"/>
               </a:rPr>
               <a:t>📊 Click for interactive version</a:t>
             </a:r>
@@ -6156,7 +6180,9 @@
       </p:sp>
       <p:sp>
         <p:nvSpPr>
-          <p:cNvPr id="3" name="TextBox 2"/>
+          <p:cNvPr id="3" name="TextBox 2">
+            <a:hlinkClick r:id="rId2"/>
+          </p:cNvPr>
           <p:cNvSpPr txBox="1"/>
           <p:nvPr/>
         </p:nvSpPr>
@@ -6181,7 +6207,7 @@
                 <a:solidFill>
                   <a:srgbClr val="646464"/>
                 </a:solidFill>
-                <a:hlinkClick r:id="rId2"/>
+                <a:hlinkClick r:id="rId2" tooltip="Key leverage metric showing how many years of earnings to repay debt. Below 3x is healthy; above 5x is risky."/>
               </a:rPr>
               <a:t>ⓘ</a:t>
             </a:r>
@@ -6249,7 +6275,9 @@
       </p:sp>
       <p:sp>
         <p:nvSpPr>
-          <p:cNvPr id="6" name="TextBox 5"/>
+          <p:cNvPr id="6" name="TextBox 5">
+            <a:hlinkClick r:id="rId2"/>
+          </p:cNvPr>
           <p:cNvSpPr txBox="1"/>
           <p:nvPr/>
         </p:nvSpPr>
@@ -6274,7 +6302,6 @@
                 <a:solidFill>
                   <a:srgbClr val="0066CC"/>
                 </a:solidFill>
-                <a:hlinkClick r:id="rId2"/>
               </a:rPr>
               <a:t>📊 Click for interactive version</a:t>
             </a:r>
@@ -6336,7 +6363,9 @@
       </p:sp>
       <p:sp>
         <p:nvSpPr>
-          <p:cNvPr id="3" name="TextBox 2"/>
+          <p:cNvPr id="3" name="TextBox 2">
+            <a:hlinkClick r:id="rId2"/>
+          </p:cNvPr>
           <p:cNvSpPr txBox="1"/>
           <p:nvPr/>
         </p:nvSpPr>
@@ -6361,7 +6390,7 @@
                 <a:solidFill>
                   <a:srgbClr val="646464"/>
                 </a:solidFill>
-                <a:hlinkClick r:id="rId2"/>
+                <a:hlinkClick r:id="rId2" tooltip="Interest coverage ratio tracking. Above 3x is comfortable; below 2x requires monitoring."/>
               </a:rPr>
               <a:t>ⓘ</a:t>
             </a:r>
@@ -6429,7 +6458,9 @@
       </p:sp>
       <p:sp>
         <p:nvSpPr>
-          <p:cNvPr id="6" name="TextBox 5"/>
+          <p:cNvPr id="6" name="TextBox 5">
+            <a:hlinkClick r:id="rId2"/>
+          </p:cNvPr>
           <p:cNvSpPr txBox="1"/>
           <p:nvPr/>
         </p:nvSpPr>
@@ -6454,7 +6485,6 @@
                 <a:solidFill>
                   <a:srgbClr val="0066CC"/>
                 </a:solidFill>
-                <a:hlinkClick r:id="rId2"/>
               </a:rPr>
               <a:t>📊 Click for interactive version</a:t>
             </a:r>
@@ -6516,7 +6546,9 @@
       </p:sp>
       <p:sp>
         <p:nvSpPr>
-          <p:cNvPr id="3" name="TextBox 2"/>
+          <p:cNvPr id="3" name="TextBox 2">
+            <a:hlinkClick r:id="rId2"/>
+          </p:cNvPr>
           <p:cNvSpPr txBox="1"/>
           <p:nvPr/>
         </p:nvSpPr>
@@ -6541,7 +6573,7 @@
                 <a:solidFill>
                   <a:srgbClr val="646464"/>
                 </a:solidFill>
-                <a:hlinkClick r:id="rId2"/>
+                <a:hlinkClick r:id="rId2" tooltip="Three cash flow lines: Operating, Investing, Financing. Operating should be consistently positive."/>
               </a:rPr>
               <a:t>ⓘ</a:t>
             </a:r>
@@ -6609,7 +6641,9 @@
       </p:sp>
       <p:sp>
         <p:nvSpPr>
-          <p:cNvPr id="6" name="TextBox 5"/>
+          <p:cNvPr id="6" name="TextBox 5">
+            <a:hlinkClick r:id="rId2"/>
+          </p:cNvPr>
           <p:cNvSpPr txBox="1"/>
           <p:nvPr/>
         </p:nvSpPr>
@@ -6634,7 +6668,6 @@
                 <a:solidFill>
                   <a:srgbClr val="0066CC"/>
                 </a:solidFill>
-                <a:hlinkClick r:id="rId2"/>
               </a:rPr>
               <a:t>📊 Click for interactive version</a:t>
             </a:r>
@@ -7264,7 +7297,9 @@
       </p:sp>
       <p:sp>
         <p:nvSpPr>
-          <p:cNvPr id="3" name="TextBox 2"/>
+          <p:cNvPr id="3" name="TextBox 2">
+            <a:hlinkClick r:id="rId2"/>
+          </p:cNvPr>
           <p:cNvSpPr txBox="1"/>
           <p:nvPr/>
         </p:nvSpPr>
@@ -7289,7 +7324,7 @@
                 <a:solidFill>
                   <a:srgbClr val="646464"/>
                 </a:solidFill>
-                <a:hlinkClick r:id="rId2"/>
+                <a:hlinkClick r:id="rId2" tooltip="Decomposes ROE into Profit Margin x Asset Turnover x Financial Leverage. Shows what drives returns."/>
               </a:rPr>
               <a:t>ⓘ</a:t>
             </a:r>
@@ -7357,7 +7392,9 @@
       </p:sp>
       <p:sp>
         <p:nvSpPr>
-          <p:cNvPr id="6" name="TextBox 5"/>
+          <p:cNvPr id="6" name="TextBox 5">
+            <a:hlinkClick r:id="rId2"/>
+          </p:cNvPr>
           <p:cNvSpPr txBox="1"/>
           <p:nvPr/>
         </p:nvSpPr>
@@ -7382,7 +7419,6 @@
                 <a:solidFill>
                   <a:srgbClr val="0066CC"/>
                 </a:solidFill>
-                <a:hlinkClick r:id="rId2"/>
               </a:rPr>
               <a:t>📊 Click for interactive version</a:t>
             </a:r>
@@ -7444,7 +7480,9 @@
       </p:sp>
       <p:sp>
         <p:nvSpPr>
-          <p:cNvPr id="3" name="TextBox 2"/>
+          <p:cNvPr id="3" name="TextBox 2">
+            <a:hlinkClick r:id="rId2"/>
+          </p:cNvPr>
           <p:cNvSpPr txBox="1"/>
           <p:nvPr/>
         </p:nvSpPr>
@@ -7469,7 +7507,7 @@
                 <a:solidFill>
                   <a:srgbClr val="646464"/>
                 </a:solidFill>
-                <a:hlinkClick r:id="rId2"/>
+                <a:hlinkClick r:id="rId2" tooltip="Tracks turnover ratio and days on hand. Faster turns = less capital tied up in inventory."/>
               </a:rPr>
               <a:t>ⓘ</a:t>
             </a:r>
@@ -7537,7 +7575,9 @@
       </p:sp>
       <p:sp>
         <p:nvSpPr>
-          <p:cNvPr id="6" name="TextBox 5"/>
+          <p:cNvPr id="6" name="TextBox 5">
+            <a:hlinkClick r:id="rId2"/>
+          </p:cNvPr>
           <p:cNvSpPr txBox="1"/>
           <p:nvPr/>
         </p:nvSpPr>
@@ -7562,7 +7602,6 @@
                 <a:solidFill>
                   <a:srgbClr val="0066CC"/>
                 </a:solidFill>
-                <a:hlinkClick r:id="rId2"/>
               </a:rPr>
               <a:t>📊 Click for interactive version</a:t>
             </a:r>
@@ -7624,7 +7663,9 @@
       </p:sp>
       <p:sp>
         <p:nvSpPr>
-          <p:cNvPr id="3" name="TextBox 2"/>
+          <p:cNvPr id="3" name="TextBox 2">
+            <a:hlinkClick r:id="rId2"/>
+          </p:cNvPr>
           <p:cNvSpPr txBox="1"/>
           <p:nvPr/>
         </p:nvSpPr>
@@ -7649,7 +7690,7 @@
                 <a:solidFill>
                   <a:srgbClr val="646464"/>
                 </a:solidFill>
-                <a:hlinkClick r:id="rId2"/>
+                <a:hlinkClick r:id="rId2" tooltip="Days to convert inventory to cash vs retail peers. Lower is better; negative means suppliers finance operations."/>
               </a:rPr>
               <a:t>ⓘ</a:t>
             </a:r>
@@ -7717,7 +7758,9 @@
       </p:sp>
       <p:sp>
         <p:nvSpPr>
-          <p:cNvPr id="6" name="TextBox 5"/>
+          <p:cNvPr id="6" name="TextBox 5">
+            <a:hlinkClick r:id="rId2"/>
+          </p:cNvPr>
           <p:cNvSpPr txBox="1"/>
           <p:nvPr/>
         </p:nvSpPr>
@@ -7742,7 +7785,6 @@
                 <a:solidFill>
                   <a:srgbClr val="0066CC"/>
                 </a:solidFill>
-                <a:hlinkClick r:id="rId2"/>
               </a:rPr>
               <a:t>📊 Click for interactive version</a:t>
             </a:r>
@@ -7804,7 +7846,9 @@
       </p:sp>
       <p:sp>
         <p:nvSpPr>
-          <p:cNvPr id="3" name="TextBox 2"/>
+          <p:cNvPr id="3" name="TextBox 2">
+            <a:hlinkClick r:id="rId2"/>
+          </p:cNvPr>
           <p:cNvSpPr txBox="1"/>
           <p:nvPr/>
         </p:nvSpPr>
@@ -7829,7 +7873,7 @@
                 <a:solidFill>
                   <a:srgbClr val="646464"/>
                 </a:solidFill>
-                <a:hlinkClick r:id="rId2"/>
+                <a:hlinkClick r:id="rId2" tooltip="Compares TGT total return vs S&amp;P 500 (SPY) and Retail ETF (XRT). Rolling beta shows stock's sensitivity to market movements."/>
               </a:rPr>
               <a:t>ⓘ</a:t>
             </a:r>
@@ -7897,7 +7941,9 @@
       </p:sp>
       <p:sp>
         <p:nvSpPr>
-          <p:cNvPr id="6" name="TextBox 5"/>
+          <p:cNvPr id="6" name="TextBox 5">
+            <a:hlinkClick r:id="rId2"/>
+          </p:cNvPr>
           <p:cNvSpPr txBox="1"/>
           <p:nvPr/>
         </p:nvSpPr>
@@ -7922,7 +7968,6 @@
                 <a:solidFill>
                   <a:srgbClr val="0066CC"/>
                 </a:solidFill>
-                <a:hlinkClick r:id="rId2"/>
               </a:rPr>
               <a:t>📊 Click for interactive version</a:t>
             </a:r>
@@ -7984,7 +8029,9 @@
       </p:sp>
       <p:sp>
         <p:nvSpPr>
-          <p:cNvPr id="3" name="TextBox 2"/>
+          <p:cNvPr id="3" name="TextBox 2">
+            <a:hlinkClick r:id="rId2"/>
+          </p:cNvPr>
           <p:cNvSpPr txBox="1"/>
           <p:nvPr/>
         </p:nvSpPr>
@@ -8009,7 +8056,7 @@
                 <a:solidFill>
                   <a:srgbClr val="646464"/>
                 </a:solidFill>
-                <a:hlinkClick r:id="rId2"/>
+                <a:hlinkClick r:id="rId2" tooltip="Operating cash vs capital spending. The gap between them is Free Cash Flow available for shareholders."/>
               </a:rPr>
               <a:t>ⓘ</a:t>
             </a:r>
@@ -8077,7 +8124,9 @@
       </p:sp>
       <p:sp>
         <p:nvSpPr>
-          <p:cNvPr id="6" name="TextBox 5"/>
+          <p:cNvPr id="6" name="TextBox 5">
+            <a:hlinkClick r:id="rId2"/>
+          </p:cNvPr>
           <p:cNvSpPr txBox="1"/>
           <p:nvPr/>
         </p:nvSpPr>
@@ -8102,7 +8151,6 @@
                 <a:solidFill>
                   <a:srgbClr val="0066CC"/>
                 </a:solidFill>
-                <a:hlinkClick r:id="rId2"/>
               </a:rPr>
               <a:t>📊 Click for interactive version</a:t>
             </a:r>
@@ -8732,7 +8780,9 @@
       </p:sp>
       <p:sp>
         <p:nvSpPr>
-          <p:cNvPr id="3" name="TextBox 2"/>
+          <p:cNvPr id="3" name="TextBox 2">
+            <a:hlinkClick r:id="rId2"/>
+          </p:cNvPr>
           <p:cNvSpPr txBox="1"/>
           <p:nvPr/>
         </p:nvSpPr>
@@ -8757,7 +8807,7 @@
                 <a:solidFill>
                   <a:srgbClr val="646464"/>
                 </a:solidFill>
-                <a:hlinkClick r:id="rId2"/>
+                <a:hlinkClick r:id="rId2" tooltip="P/E ratio vs revenue growth for Target and peers. Lower-right quadrant = undervalued opportunities."/>
               </a:rPr>
               <a:t>ⓘ</a:t>
             </a:r>
@@ -8825,7 +8875,9 @@
       </p:sp>
       <p:sp>
         <p:nvSpPr>
-          <p:cNvPr id="6" name="TextBox 5"/>
+          <p:cNvPr id="6" name="TextBox 5">
+            <a:hlinkClick r:id="rId2"/>
+          </p:cNvPr>
           <p:cNvSpPr txBox="1"/>
           <p:nvPr/>
         </p:nvSpPr>
@@ -8850,7 +8902,6 @@
                 <a:solidFill>
                   <a:srgbClr val="0066CC"/>
                 </a:solidFill>
-                <a:hlinkClick r:id="rId2"/>
               </a:rPr>
               <a:t>📊 Click for interactive version</a:t>
             </a:r>
@@ -8912,7 +8963,9 @@
       </p:sp>
       <p:sp>
         <p:nvSpPr>
-          <p:cNvPr id="3" name="TextBox 2"/>
+          <p:cNvPr id="3" name="TextBox 2">
+            <a:hlinkClick r:id="rId2"/>
+          </p:cNvPr>
           <p:cNvSpPr txBox="1"/>
           <p:nvPr/>
         </p:nvSpPr>
@@ -8937,7 +8990,7 @@
                 <a:solidFill>
                   <a:srgbClr val="646464"/>
                 </a:solidFill>
-                <a:hlinkClick r:id="rId2"/>
+                <a:hlinkClick r:id="rId2" tooltip="Current price vs historical valuation range. Below 25th percentile = historically undervalued."/>
               </a:rPr>
               <a:t>ⓘ</a:t>
             </a:r>
@@ -9005,7 +9058,9 @@
       </p:sp>
       <p:sp>
         <p:nvSpPr>
-          <p:cNvPr id="6" name="TextBox 5"/>
+          <p:cNvPr id="6" name="TextBox 5">
+            <a:hlinkClick r:id="rId2"/>
+          </p:cNvPr>
           <p:cNvSpPr txBox="1"/>
           <p:nvPr/>
         </p:nvSpPr>
@@ -9030,7 +9085,6 @@
                 <a:solidFill>
                   <a:srgbClr val="0066CC"/>
                 </a:solidFill>
-                <a:hlinkClick r:id="rId2"/>
               </a:rPr>
               <a:t>📊 Click for interactive version</a:t>
             </a:r>
@@ -9092,7 +9146,9 @@
       </p:sp>
       <p:sp>
         <p:nvSpPr>
-          <p:cNvPr id="3" name="TextBox 2"/>
+          <p:cNvPr id="3" name="TextBox 2">
+            <a:hlinkClick r:id="rId2"/>
+          </p:cNvPr>
           <p:cNvSpPr txBox="1"/>
           <p:nvPr/>
         </p:nvSpPr>
@@ -9117,7 +9173,7 @@
                 <a:solidFill>
                   <a:srgbClr val="646464"/>
                 </a:solidFill>
-                <a:hlinkClick r:id="rId2"/>
+                <a:hlinkClick r:id="rId2" tooltip="Visualizes cash allocation: CapEx, dividends, buybacks, debt repayment. Shows management priorities."/>
               </a:rPr>
               <a:t>ⓘ</a:t>
             </a:r>
@@ -9185,7 +9241,9 @@
       </p:sp>
       <p:sp>
         <p:nvSpPr>
-          <p:cNvPr id="6" name="TextBox 5"/>
+          <p:cNvPr id="6" name="TextBox 5">
+            <a:hlinkClick r:id="rId2"/>
+          </p:cNvPr>
           <p:cNvSpPr txBox="1"/>
           <p:nvPr/>
         </p:nvSpPr>
@@ -9210,7 +9268,6 @@
                 <a:solidFill>
                   <a:srgbClr val="0066CC"/>
                 </a:solidFill>
-                <a:hlinkClick r:id="rId2"/>
               </a:rPr>
               <a:t>📊 Click for interactive version</a:t>
             </a:r>
@@ -9272,7 +9329,9 @@
       </p:sp>
       <p:sp>
         <p:nvSpPr>
-          <p:cNvPr id="3" name="TextBox 2"/>
+          <p:cNvPr id="3" name="TextBox 2">
+            <a:hlinkClick r:id="rId2"/>
+          </p:cNvPr>
           <p:cNvSpPr txBox="1"/>
           <p:nvPr/>
         </p:nvSpPr>
@@ -9297,7 +9356,7 @@
                 <a:solidFill>
                   <a:srgbClr val="646464"/>
                 </a:solidFill>
-                <a:hlinkClick r:id="rId2"/>
+                <a:hlinkClick r:id="rId2" tooltip="Stacked area of risk mentions (shrink, theft, markdown) over time. Rising trends signal increasing concerns."/>
               </a:rPr>
               <a:t>ⓘ</a:t>
             </a:r>
@@ -9365,7 +9424,9 @@
       </p:sp>
       <p:sp>
         <p:nvSpPr>
-          <p:cNvPr id="6" name="TextBox 5"/>
+          <p:cNvPr id="6" name="TextBox 5">
+            <a:hlinkClick r:id="rId2"/>
+          </p:cNvPr>
           <p:cNvSpPr txBox="1"/>
           <p:nvPr/>
         </p:nvSpPr>
@@ -9390,7 +9451,6 @@
                 <a:solidFill>
                   <a:srgbClr val="0066CC"/>
                 </a:solidFill>
-                <a:hlinkClick r:id="rId2"/>
               </a:rPr>
               <a:t>📊 Click for interactive version</a:t>
             </a:r>
@@ -9452,7 +9512,9 @@
       </p:sp>
       <p:sp>
         <p:nvSpPr>
-          <p:cNvPr id="3" name="TextBox 2"/>
+          <p:cNvPr id="3" name="TextBox 2">
+            <a:hlinkClick r:id="rId2"/>
+          </p:cNvPr>
           <p:cNvSpPr txBox="1"/>
           <p:nvPr/>
         </p:nvSpPr>
@@ -9477,7 +9539,7 @@
                 <a:solidFill>
                   <a:srgbClr val="646464"/>
                 </a:solidFill>
-                <a:hlinkClick r:id="rId2"/>
+                <a:hlinkClick r:id="rId2" tooltip="Intensity grid showing risk types by period. Dark cells = high concern in that area."/>
               </a:rPr>
               <a:t>ⓘ</a:t>
             </a:r>
@@ -9545,7 +9607,9 @@
       </p:sp>
       <p:sp>
         <p:nvSpPr>
-          <p:cNvPr id="6" name="TextBox 5"/>
+          <p:cNvPr id="6" name="TextBox 5">
+            <a:hlinkClick r:id="rId2"/>
+          </p:cNvPr>
           <p:cNvSpPr txBox="1"/>
           <p:nvPr/>
         </p:nvSpPr>
@@ -9570,7 +9634,6 @@
                 <a:solidFill>
                   <a:srgbClr val="0066CC"/>
                 </a:solidFill>
-                <a:hlinkClick r:id="rId2"/>
               </a:rPr>
               <a:t>📊 Click for interactive version</a:t>
             </a:r>
@@ -10372,7 +10435,9 @@
       </p:sp>
       <p:sp>
         <p:nvSpPr>
-          <p:cNvPr id="3" name="TextBox 2"/>
+          <p:cNvPr id="3" name="TextBox 2">
+            <a:hlinkClick r:id="rId2"/>
+          </p:cNvPr>
           <p:cNvSpPr txBox="1"/>
           <p:nvPr/>
         </p:nvSpPr>
@@ -10397,7 +10462,7 @@
                 <a:solidFill>
                   <a:srgbClr val="646464"/>
                 </a:solidFill>
-                <a:hlinkClick r:id="rId2"/>
+                <a:hlinkClick r:id="rId2" tooltip="Shows Target's 10-year revenue and net income trajectory from annual 10-K filings. Look for consistent growth and whether profits keep pace with revenue."/>
               </a:rPr>
               <a:t>ⓘ</a:t>
             </a:r>
@@ -10465,7 +10530,9 @@
       </p:sp>
       <p:sp>
         <p:nvSpPr>
-          <p:cNvPr id="6" name="TextBox 5"/>
+          <p:cNvPr id="6" name="TextBox 5">
+            <a:hlinkClick r:id="rId2"/>
+          </p:cNvPr>
           <p:cNvSpPr txBox="1"/>
           <p:nvPr/>
         </p:nvSpPr>
@@ -10490,7 +10557,6 @@
                 <a:solidFill>
                   <a:srgbClr val="0066CC"/>
                 </a:solidFill>
-                <a:hlinkClick r:id="rId2"/>
               </a:rPr>
               <a:t>📊 Click for interactive version</a:t>
             </a:r>
@@ -10552,7 +10618,9 @@
       </p:sp>
       <p:sp>
         <p:nvSpPr>
-          <p:cNvPr id="3" name="TextBox 2"/>
+          <p:cNvPr id="3" name="TextBox 2">
+            <a:hlinkClick r:id="rId2"/>
+          </p:cNvPr>
           <p:cNvSpPr txBox="1"/>
           <p:nvPr/>
         </p:nvSpPr>
@@ -10577,7 +10645,7 @@
                 <a:solidFill>
                   <a:srgbClr val="646464"/>
                 </a:solidFill>
-                <a:hlinkClick r:id="rId2"/>
+                <a:hlinkClick r:id="rId2" tooltip="Tracks year-over-year revenue growth rates by quarter. Reveals acceleration or deceleration in growth momentum."/>
               </a:rPr>
               <a:t>ⓘ</a:t>
             </a:r>
@@ -10645,7 +10713,9 @@
       </p:sp>
       <p:sp>
         <p:nvSpPr>
-          <p:cNvPr id="6" name="TextBox 5"/>
+          <p:cNvPr id="6" name="TextBox 5">
+            <a:hlinkClick r:id="rId2"/>
+          </p:cNvPr>
           <p:cNvSpPr txBox="1"/>
           <p:nvPr/>
         </p:nvSpPr>
@@ -10670,7 +10740,6 @@
                 <a:solidFill>
                   <a:srgbClr val="0066CC"/>
                 </a:solidFill>
-                <a:hlinkClick r:id="rId2"/>
               </a:rPr>
               <a:t>📊 Click for interactive version</a:t>
             </a:r>
@@ -10732,7 +10801,9 @@
       </p:sp>
       <p:sp>
         <p:nvSpPr>
-          <p:cNvPr id="3" name="TextBox 2"/>
+          <p:cNvPr id="3" name="TextBox 2">
+            <a:hlinkClick r:id="rId2"/>
+          </p:cNvPr>
           <p:cNvSpPr txBox="1"/>
           <p:nvPr/>
         </p:nvSpPr>
@@ -10757,7 +10828,7 @@
                 <a:solidFill>
                   <a:srgbClr val="646464"/>
                 </a:solidFill>
-                <a:hlinkClick r:id="rId2"/>
+                <a:hlinkClick r:id="rId2" tooltip="Compares revenue growth to inventory buildup. Inventory growing faster than sales signals potential markdown risk."/>
               </a:rPr>
               <a:t>ⓘ</a:t>
             </a:r>
@@ -10825,7 +10896,9 @@
       </p:sp>
       <p:sp>
         <p:nvSpPr>
-          <p:cNvPr id="6" name="TextBox 5"/>
+          <p:cNvPr id="6" name="TextBox 5">
+            <a:hlinkClick r:id="rId2"/>
+          </p:cNvPr>
           <p:cNvSpPr txBox="1"/>
           <p:nvPr/>
         </p:nvSpPr>
@@ -10850,7 +10923,6 @@
                 <a:solidFill>
                   <a:srgbClr val="0066CC"/>
                 </a:solidFill>
-                <a:hlinkClick r:id="rId2"/>
               </a:rPr>
               <a:t>📊 Click for interactive version</a:t>
             </a:r>
@@ -10912,7 +10984,9 @@
       </p:sp>
       <p:sp>
         <p:nvSpPr>
-          <p:cNvPr id="3" name="TextBox 2"/>
+          <p:cNvPr id="3" name="TextBox 2">
+            <a:hlinkClick r:id="rId2"/>
+          </p:cNvPr>
           <p:cNvSpPr txBox="1"/>
           <p:nvPr/>
         </p:nvSpPr>
@@ -10937,7 +11011,7 @@
                 <a:solidFill>
                   <a:srgbClr val="646464"/>
                 </a:solidFill>
-                <a:hlinkClick r:id="rId2"/>
+                <a:hlinkClick r:id="rId2" tooltip="Quarterly view with calculated Q4 data showing seasonal patterns. Q4 (holiday season) typically shows peak revenue."/>
               </a:rPr>
               <a:t>ⓘ</a:t>
             </a:r>
@@ -11005,7 +11079,9 @@
       </p:sp>
       <p:sp>
         <p:nvSpPr>
-          <p:cNvPr id="6" name="TextBox 5"/>
+          <p:cNvPr id="6" name="TextBox 5">
+            <a:hlinkClick r:id="rId2"/>
+          </p:cNvPr>
           <p:cNvSpPr txBox="1"/>
           <p:nvPr/>
         </p:nvSpPr>
@@ -11030,7 +11106,6 @@
                 <a:solidFill>
                   <a:srgbClr val="0066CC"/>
                 </a:solidFill>
-                <a:hlinkClick r:id="rId2"/>
               </a:rPr>
               <a:t>📊 Click for interactive version</a:t>
             </a:r>

</xml_diff>